<commit_message>
Aggiornamenti finali presentazione PowerPoint
</commit_message>
<xml_diff>
--- a/Login_passwordless.pptx
+++ b/Login_passwordless.pptx
@@ -3421,13 +3421,27 @@
           <a:p>
             <a:r>
               <a:rPr lang="it-IT" dirty="0"/>
-              <a:t>Il token viene inviato all’utente tramite un link via e-mail.</a:t>
+              <a:t>Il server costruisce l’URL personalizzato e lo recapita all’utente tramite posta elettronica.</a:t>
             </a:r>
           </a:p>
           <a:p>
             <a:r>
               <a:rPr lang="it-IT" dirty="0"/>
               <a:t>Al click, il server verifica la validità del token e autorizza l’accesso.</a:t>
+            </a:r>
+          </a:p>
+          <a:p>
+            <a:r>
+              <a:rPr lang="it-IT" dirty="0"/>
+              <a:t>In caso di successo, il </a:t>
+            </a:r>
+            <a:r>
+              <a:rPr lang="it-IT"/>
+              <a:t>token viene eliminato </a:t>
+            </a:r>
+            <a:r>
+              <a:rPr lang="it-IT" dirty="0"/>
+              <a:t>e l’utente viene reindirizzato nell’area protetta.</a:t>
             </a:r>
           </a:p>
         </p:txBody>
@@ -3841,7 +3855,7 @@
           <a:p>
             <a:r>
               <a:rPr lang="it-IT" dirty="0"/>
-              <a:t>Il server decifra la firma e autorizza l’accesso.</a:t>
+              <a:t>Il server verifica la firma tramite la chiave pubblica e autorizza l’accesso.</a:t>
             </a:r>
           </a:p>
         </p:txBody>
@@ -3915,17 +3929,20 @@
           <a:lstStyle/>
           <a:p>
             <a:r>
-              <a:rPr lang="it-IT"/>
-              <a:t>FIDO2 / WebAuthn</a:t>
+              <a:rPr lang="it-IT" dirty="0"/>
+              <a:t>FIDO2 / </a:t>
+            </a:r>
+            <a:r>
+              <a:rPr lang="it-IT" dirty="0" err="1"/>
+              <a:t>WebAuthn</a:t>
             </a:r>
             <a:br>
-              <a:rPr lang="it-IT"/>
+              <a:rPr lang="it-IT" dirty="0"/>
             </a:br>
             <a:r>
-              <a:rPr lang="it-IT"/>
-              <a:t>Registrazione diretta</a:t>
-            </a:r>
-            <a:endParaRPr lang="it-IT" dirty="0"/>
+              <a:rPr lang="it-IT" dirty="0"/>
+              <a:t>Sicurezza</a:t>
+            </a:r>
           </a:p>
         </p:txBody>
       </p:sp>

</xml_diff>